<commit_message>
Remove deck build sources from public repo
</commit_message>
<xml_diff>
--- a/week_07/Week_07_Postgres_to_NoSQL_Bridge.pptx
+++ b/week_07/Week_07_Postgres_to_NoSQL_Bridge.pptx
@@ -505,23 +505,7 @@
         <p:txBody>
           <a:bodyPr/>
           <a:lstStyle/>
-          <a:p>
-            <a:r>
-              <a:t>Use this as the closing bridge after the PostgreSQL wrap-up, not as a full MongoDB lecture. The goal is to widen the students' mental model before Week 8, not to start a new syntax-heavy unit too early.</a:t>
-            </a:r>
-          </a:p>
           <a:p/>
-          <a:p>
-            <a:r>
-              <a:t>Keep the contrast clean: Weeks 1 through 7 taught relational design, PostgreSQL operations, concurrency, and maintenance. The bridge asks a new question: what happens when the workload does not fit the default relational shape as neatly?</a:t>
-            </a:r>
-          </a:p>
-          <a:p/>
-          <a:p>
-            <a:r>
-              <a:t>Students should leave Week 7 with a map of why NoSQL became important and what the major families are. Week 8 will then spend its time on MongoDB-specific modeling and query patterns.</a:t>
-            </a:r>
-          </a:p>
         </p:txBody>
       </p:sp>
       <p:sp>
@@ -587,23 +571,7 @@
         <p:txBody>
           <a:bodyPr/>
           <a:lstStyle/>
-          <a:p>
-            <a:r>
-              <a:t>Students can misread this transition if it is rushed. Say plainly that PostgreSQL remains important and that the course is not declaring relational databases outdated.</a:t>
-            </a:r>
-          </a:p>
           <a:p/>
-          <a:p>
-            <a:r>
-              <a:t>What changes is the scope of the DBA mindset. A strong administrator should be able to explain when a document model, graph model, or key-value model better fits the problem at hand. That is what makes this bridge useful.</a:t>
-            </a:r>
-          </a:p>
-          <a:p/>
-          <a:p>
-            <a:r>
-              <a:t>If you want a one-line summary for students, use this: 'We are not leaving databases behind; we are learning that databases come in multiple shapes for multiple workloads.'</a:t>
-            </a:r>
-          </a:p>
         </p:txBody>
       </p:sp>
       <p:sp>
@@ -669,23 +637,7 @@
         <p:txBody>
           <a:bodyPr/>
           <a:lstStyle/>
-          <a:p>
-            <a:r>
-              <a:t>Do not over-teach the timeline here. The purpose is to correct the simplified story that everything was relational until one vendor invented something modern.</a:t>
-            </a:r>
-          </a:p>
           <a:p/>
-          <a:p>
-            <a:r>
-              <a:t>The better story is that relational systems solved major problems elegantly, but later internet-scale workloads reopened older questions under new conditions such as distribution, replication, and flexible application-shaped records.</a:t>
-            </a:r>
-          </a:p>
-          <a:p/>
-          <a:p>
-            <a:r>
-              <a:t>You only need enough history for students to understand cause and effect. The detailed MongoDB content belongs in Week 8.</a:t>
-            </a:r>
-          </a:p>
         </p:txBody>
       </p:sp>
       <p:sp>
@@ -751,23 +703,7 @@
         <p:txBody>
           <a:bodyPr/>
           <a:lstStyle/>
-          <a:p>
-            <a:r>
-              <a:t>This slide should give students a compact territory map. Keep one workload image attached to each family so the terms do not stay abstract.</a:t>
-            </a:r>
-          </a:p>
           <a:p/>
-          <a:p>
-            <a:r>
-              <a:t>Key-value is 'return by key fast.' Document is 'store an application-shaped record.' Column-family is 'high-volume wide or time-windowed data.' Graph is 'follow relationships efficiently.'</a:t>
-            </a:r>
-          </a:p>
-          <a:p/>
-          <a:p>
-            <a:r>
-              <a:t>At this point, tell students that Week 8 will focus on the document family because MongoDB is a practical and teachable next step from the course's existing database knowledge.</a:t>
-            </a:r>
-          </a:p>
         </p:txBody>
       </p:sp>
       <p:sp>
@@ -833,23 +769,7 @@
         <p:txBody>
           <a:bodyPr/>
           <a:lstStyle/>
-          <a:p>
-            <a:r>
-              <a:t>Keep this slide at teaser level. The point is to give students one concrete image of a document so Week 8 does not begin from zero.</a:t>
-            </a:r>
-          </a:p>
           <a:p/>
-          <a:p>
-            <a:r>
-              <a:t>Say clearly that a document database is not an excuse to stop modeling. The reason MongoDB is useful is that some workloads naturally read and write a whole aggregate together. That is the modeling question Week 8 will answer in more detail.</a:t>
-            </a:r>
-          </a:p>
-          <a:p/>
-          <a:p>
-            <a:r>
-              <a:t>Connect back to the DBA role. Even in a flexible document system, you still have to think about validation, indexing, recovery, and observability.</a:t>
-            </a:r>
-          </a:p>
         </p:txBody>
       </p:sp>
       <p:sp>
@@ -915,23 +835,7 @@
         <p:txBody>
           <a:bodyPr/>
           <a:lstStyle/>
-          <a:p>
-            <a:r>
-              <a:t>End the bridge by making students anticipate the next class. If they can already name a relational-shaped workload and a document-shaped workload, they are ready for Week 8.</a:t>
-            </a:r>
-          </a:p>
           <a:p/>
-          <a:p>
-            <a:r>
-              <a:t>You do not need to resolve every modeling question here. The goal is to create curiosity and enough vocabulary that the next lecture can move faster without feeling abrupt.</a:t>
-            </a:r>
-          </a:p>
-          <a:p/>
-          <a:p>
-            <a:r>
-              <a:t>If you assign the review packet after Week 7, tell students they only need to attempt the history and classification pieces before Week 8. The MongoDB-specific sections can wait until after the next class.</a:t>
-            </a:r>
-          </a:p>
         </p:txBody>
       </p:sp>
       <p:sp>

</xml_diff>